<commit_message>
Rebuild slide 06 client footprint as editable map slide
Native US map with pins as PowerPoint shapes, ready to take a
per-site pin for every serviced location once the site list arrives.

Co-Authored-By: Claude Opus 5.5 <noreply@anthropic.com>
Claude-Session: https://claude.ai/code/session_012Xgw1SR6JB66tqo8Xp5ptX
</commit_message>
<xml_diff>
--- a/DSS_CIM_Deck_final.pptx
+++ b/DSS_CIM_Deck_final.pptx
@@ -2824,14 +2824,14 @@
       </p:grpSpPr>
       <p:pic>
         <p:nvPicPr>
-          <p:cNvPr id="2" name="Image 0" descr="/tmp/claude-0/-home-claude/8e0ee671-14e5-50f2-92d6-eb46531718ab/scratchpad/dss_deck/pptx_slide-06.png">    </p:cNvPr>
+          <p:cNvPr id="2" name="Background" descr="Background"/>
           <p:cNvPicPr>
             <a:picLocks noChangeAspect="1"/>
           </p:cNvPicPr>
           <p:nvPr/>
         </p:nvPicPr>
         <p:blipFill>
-          <a:blip r:embed="rId1"/>
+          <a:blip r:embed="rId10"/>
           <a:stretch>
             <a:fillRect/>
           </a:stretch>
@@ -2839,13 +2839,1297 @@
         <p:spPr>
           <a:xfrm>
             <a:off x="0" y="0"/>
-            <a:ext cx="12191695" cy="6858000"/>
+            <a:ext cx="12192000" cy="6858000"/>
           </a:xfrm>
           <a:prstGeom prst="rect">
             <a:avLst/>
           </a:prstGeom>
         </p:spPr>
       </p:pic>
+      <p:sp>
+        <p:nvSpPr>
+          <p:cNvPr id="3" name="Text 3"/>
+          <p:cNvSpPr txBox="1"/>
+          <p:nvPr/>
+        </p:nvSpPr>
+        <p:spPr>
+          <a:xfrm>
+            <a:off x="762000" y="682752"/>
+            <a:ext cx="5486400" cy="158496"/>
+          </a:xfrm>
+          <a:prstGeom prst="rect">
+            <a:avLst/>
+          </a:prstGeom>
+          <a:noFill/>
+        </p:spPr>
+        <p:txBody>
+          <a:bodyPr wrap="square" lIns="0" tIns="0" rIns="0" bIns="0" anchor="t">
+            <a:noAutofit/>
+          </a:bodyPr>
+          <a:lstStyle/>
+          <a:p>
+            <a:pPr algn="l">
+              <a:spcAft>
+                <a:spcPts val="300"/>
+              </a:spcAft>
+            </a:pPr>
+            <a:r>
+              <a:rPr lang="en-US" sz="1300" b="1" spc="500" dirty="0">
+                <a:solidFill>
+                  <a:srgbClr val="5AB0EE"/>
+                </a:solidFill>
+                <a:latin typeface="Arial"/>
+                <a:cs typeface="Arial"/>
+              </a:rPr>
+              <a:t xml:space="preserve">CLIENT FOOTPRINT</a:t>
+            </a:r>
+          </a:p>
+        </p:txBody>
+      </p:sp>
+      <p:sp>
+        <p:nvSpPr>
+          <p:cNvPr id="4" name="Text 4"/>
+          <p:cNvSpPr txBox="1"/>
+          <p:nvPr/>
+        </p:nvSpPr>
+        <p:spPr>
+          <a:xfrm>
+            <a:off x="762000" y="914400"/>
+            <a:ext cx="10668000" cy="365760"/>
+          </a:xfrm>
+          <a:prstGeom prst="rect">
+            <a:avLst/>
+          </a:prstGeom>
+          <a:noFill/>
+        </p:spPr>
+        <p:txBody>
+          <a:bodyPr wrap="square" lIns="0" tIns="0" rIns="0" bIns="0" anchor="t">
+            <a:noAutofit/>
+          </a:bodyPr>
+          <a:lstStyle/>
+          <a:p>
+            <a:pPr algn="l">
+              <a:spcAft>
+                <a:spcPts val="300"/>
+              </a:spcAft>
+            </a:pPr>
+            <a:r>
+              <a:rPr lang="en-US" sz="3200" b="1" spc="-20" dirty="0">
+                <a:solidFill>
+                  <a:srgbClr val="FFFFFF"/>
+                </a:solidFill>
+                <a:latin typeface="Arial"/>
+                <a:cs typeface="Arial"/>
+              </a:rPr>
+              <a:t xml:space="preserve">16 clients, 300+ sites — anchored in the Northeast</a:t>
+            </a:r>
+          </a:p>
+        </p:txBody>
+      </p:sp>
+      <p:pic>
+        <p:nvPicPr>
+          <p:cNvPr id="5" name="US map" descr="US map"/>
+          <p:cNvPicPr>
+            <a:picLocks noChangeAspect="1"/>
+          </p:cNvPicPr>
+          <p:nvPr/>
+        </p:nvPicPr>
+        <p:blipFill>
+          <a:blip r:embed="rId11"/>
+          <a:stretch>
+            <a:fillRect/>
+          </a:stretch>
+        </p:blipFill>
+        <p:spPr>
+          <a:xfrm>
+            <a:off x="487680" y="1493520"/>
+            <a:ext cx="6644640" cy="4151376"/>
+          </a:xfrm>
+          <a:prstGeom prst="rect">
+            <a:avLst/>
+          </a:prstGeom>
+        </p:spPr>
+      </p:pic>
+      <p:sp>
+        <p:nvSpPr>
+          <p:cNvPr id="6" name="Glow"/>
+          <p:cNvSpPr/>
+          <p:nvPr/>
+        </p:nvSpPr>
+        <p:spPr>
+          <a:xfrm>
+            <a:off x="6239359" y="2713851"/>
+            <a:ext cx="512064" cy="512064"/>
+          </a:xfrm>
+          <a:prstGeom prst="ellipse">
+            <a:avLst/>
+          </a:prstGeom>
+          <a:solidFill>
+            <a:srgbClr val="3B82D6">
+              <a:alpha val="22000"/>
+            </a:srgbClr>
+          </a:solidFill>
+          <a:ln>
+            <a:noFill/>
+          </a:ln>
+        </p:spPr>
+      </p:sp>
+      <p:sp>
+        <p:nvSpPr>
+          <p:cNvPr id="7" name="Cluster - NY Metro &amp; Long Island"/>
+          <p:cNvSpPr/>
+          <p:nvPr/>
+        </p:nvSpPr>
+        <p:spPr>
+          <a:xfrm>
+            <a:off x="6342991" y="2817483"/>
+            <a:ext cx="304800" cy="304800"/>
+          </a:xfrm>
+          <a:prstGeom prst="ellipse">
+            <a:avLst/>
+          </a:prstGeom>
+          <a:solidFill>
+            <a:srgbClr val="3B82D6"/>
+          </a:solidFill>
+          <a:ln w="19050">
+            <a:solidFill>
+              <a:srgbClr val="FFFFFF"/>
+            </a:solidFill>
+          </a:ln>
+        </p:spPr>
+        <p:txBody>
+          <a:bodyPr lIns="0" tIns="0" rIns="0" bIns="0" anchor="ctr">
+            <a:noAutofit/>
+          </a:bodyPr>
+          <a:lstStyle/>
+          <a:p>
+            <a:pPr algn="ctr"/>
+            <a:r>
+              <a:rPr lang="en-US" sz="1600" b="1" dirty="0">
+                <a:solidFill>
+                  <a:srgbClr val="FFFFFF"/>
+                </a:solidFill>
+                <a:latin typeface="Arial"/>
+              </a:rPr>
+              <a:t>11</a:t>
+            </a:r>
+          </a:p>
+        </p:txBody>
+      </p:sp>
+      <p:sp>
+        <p:nvSpPr>
+          <p:cNvPr id="8" name="Glow"/>
+          <p:cNvSpPr/>
+          <p:nvPr/>
+        </p:nvSpPr>
+        <p:spPr>
+          <a:xfrm>
+            <a:off x="4923283" y="3041182"/>
+            <a:ext cx="316992" cy="316992"/>
+          </a:xfrm>
+          <a:prstGeom prst="ellipse">
+            <a:avLst/>
+          </a:prstGeom>
+          <a:solidFill>
+            <a:srgbClr val="3B82D6">
+              <a:alpha val="22000"/>
+            </a:srgbClr>
+          </a:solidFill>
+          <a:ln>
+            <a:noFill/>
+          </a:ln>
+        </p:spPr>
+      </p:sp>
+      <p:sp>
+        <p:nvSpPr>
+          <p:cNvPr id="9" name="Client - Midwest Eye Consultants / Bridgeview Eye"/>
+          <p:cNvSpPr/>
+          <p:nvPr/>
+        </p:nvSpPr>
+        <p:spPr>
+          <a:xfrm>
+            <a:off x="4996435" y="3114334"/>
+            <a:ext cx="170688" cy="170688"/>
+          </a:xfrm>
+          <a:prstGeom prst="ellipse">
+            <a:avLst/>
+          </a:prstGeom>
+          <a:solidFill>
+            <a:srgbClr val="3B82D6"/>
+          </a:solidFill>
+          <a:ln w="15875">
+            <a:solidFill>
+              <a:srgbClr val="FFFFFF"/>
+            </a:solidFill>
+          </a:ln>
+        </p:spPr>
+        <p:txBody>
+          <a:bodyPr lIns="0" tIns="0" rIns="0" bIns="0" anchor="ctr">
+            <a:noAutofit/>
+          </a:bodyPr>
+          <a:lstStyle/>
+          <a:p>
+            <a:pPr algn="ctr"/>
+            <a:r>
+              <a:rPr lang="en-US" sz="1100" b="1" dirty="0">
+                <a:solidFill>
+                  <a:srgbClr val="FFFFFF"/>
+                </a:solidFill>
+                <a:latin typeface="Arial"/>
+              </a:rPr>
+              <a:t>1</a:t>
+            </a:r>
+          </a:p>
+        </p:txBody>
+      </p:sp>
+      <p:sp>
+        <p:nvSpPr>
+          <p:cNvPr id="10" name="Glow"/>
+          <p:cNvSpPr/>
+          <p:nvPr/>
+        </p:nvSpPr>
+        <p:spPr>
+          <a:xfrm>
+            <a:off x="5036657" y="2736504"/>
+            <a:ext cx="316992" cy="316992"/>
+          </a:xfrm>
+          <a:prstGeom prst="ellipse">
+            <a:avLst/>
+          </a:prstGeom>
+          <a:solidFill>
+            <a:srgbClr val="3B82D6">
+              <a:alpha val="22000"/>
+            </a:srgbClr>
+          </a:solidFill>
+          <a:ln>
+            <a:noFill/>
+          </a:ln>
+        </p:spPr>
+      </p:sp>
+      <p:sp>
+        <p:nvSpPr>
+          <p:cNvPr id="11" name="Client - MMSIC"/>
+          <p:cNvSpPr/>
+          <p:nvPr/>
+        </p:nvSpPr>
+        <p:spPr>
+          <a:xfrm>
+            <a:off x="5109809" y="2809656"/>
+            <a:ext cx="170688" cy="170688"/>
+          </a:xfrm>
+          <a:prstGeom prst="ellipse">
+            <a:avLst/>
+          </a:prstGeom>
+          <a:solidFill>
+            <a:srgbClr val="3B82D6"/>
+          </a:solidFill>
+          <a:ln w="15875">
+            <a:solidFill>
+              <a:srgbClr val="FFFFFF"/>
+            </a:solidFill>
+          </a:ln>
+        </p:spPr>
+        <p:txBody>
+          <a:bodyPr lIns="0" tIns="0" rIns="0" bIns="0" anchor="ctr">
+            <a:noAutofit/>
+          </a:bodyPr>
+          <a:lstStyle/>
+          <a:p>
+            <a:pPr algn="ctr"/>
+            <a:r>
+              <a:rPr lang="en-US" sz="1100" b="1" dirty="0">
+                <a:solidFill>
+                  <a:srgbClr val="FFFFFF"/>
+                </a:solidFill>
+                <a:latin typeface="Arial"/>
+              </a:rPr>
+              <a:t>2</a:t>
+            </a:r>
+          </a:p>
+        </p:txBody>
+      </p:sp>
+      <p:sp>
+        <p:nvSpPr>
+          <p:cNvPr id="12" name="Glow"/>
+          <p:cNvSpPr/>
+          <p:nvPr/>
+        </p:nvSpPr>
+        <p:spPr>
+          <a:xfrm>
+            <a:off x="5945246" y="5046509"/>
+            <a:ext cx="316992" cy="316992"/>
+          </a:xfrm>
+          <a:prstGeom prst="ellipse">
+            <a:avLst/>
+          </a:prstGeom>
+          <a:solidFill>
+            <a:srgbClr val="3B82D6">
+              <a:alpha val="22000"/>
+            </a:srgbClr>
+          </a:solidFill>
+          <a:ln>
+            <a:noFill/>
+          </a:ln>
+        </p:spPr>
+      </p:sp>
+      <p:sp>
+        <p:nvSpPr>
+          <p:cNvPr id="13" name="Client - MyServiceReady"/>
+          <p:cNvSpPr/>
+          <p:nvPr/>
+        </p:nvSpPr>
+        <p:spPr>
+          <a:xfrm>
+            <a:off x="6018398" y="5119661"/>
+            <a:ext cx="170688" cy="170688"/>
+          </a:xfrm>
+          <a:prstGeom prst="ellipse">
+            <a:avLst/>
+          </a:prstGeom>
+          <a:solidFill>
+            <a:srgbClr val="3B82D6"/>
+          </a:solidFill>
+          <a:ln w="15875">
+            <a:solidFill>
+              <a:srgbClr val="FFFFFF"/>
+            </a:solidFill>
+          </a:ln>
+        </p:spPr>
+        <p:txBody>
+          <a:bodyPr lIns="0" tIns="0" rIns="0" bIns="0" anchor="ctr">
+            <a:noAutofit/>
+          </a:bodyPr>
+          <a:lstStyle/>
+          <a:p>
+            <a:pPr algn="ctr"/>
+            <a:r>
+              <a:rPr lang="en-US" sz="1100" b="1" dirty="0">
+                <a:solidFill>
+                  <a:srgbClr val="FFFFFF"/>
+                </a:solidFill>
+                <a:latin typeface="Arial"/>
+              </a:rPr>
+              <a:t>3</a:t>
+            </a:r>
+          </a:p>
+        </p:txBody>
+      </p:sp>
+      <p:sp>
+        <p:nvSpPr>
+          <p:cNvPr id="14" name="Glow"/>
+          <p:cNvSpPr/>
+          <p:nvPr/>
+        </p:nvSpPr>
+        <p:spPr>
+          <a:xfrm>
+            <a:off x="3931071" y="3905697"/>
+            <a:ext cx="316992" cy="316992"/>
+          </a:xfrm>
+          <a:prstGeom prst="ellipse">
+            <a:avLst/>
+          </a:prstGeom>
+          <a:solidFill>
+            <a:srgbClr val="3B82D6">
+              <a:alpha val="22000"/>
+            </a:srgbClr>
+          </a:solidFill>
+          <a:ln>
+            <a:noFill/>
+          </a:ln>
+        </p:spPr>
+      </p:sp>
+      <p:sp>
+        <p:nvSpPr>
+          <p:cNvPr id="15" name="Client - Roller Weight Loss"/>
+          <p:cNvSpPr/>
+          <p:nvPr/>
+        </p:nvSpPr>
+        <p:spPr>
+          <a:xfrm>
+            <a:off x="4004223" y="3978849"/>
+            <a:ext cx="170688" cy="170688"/>
+          </a:xfrm>
+          <a:prstGeom prst="ellipse">
+            <a:avLst/>
+          </a:prstGeom>
+          <a:solidFill>
+            <a:srgbClr val="3B82D6"/>
+          </a:solidFill>
+          <a:ln w="15875">
+            <a:solidFill>
+              <a:srgbClr val="FFFFFF"/>
+            </a:solidFill>
+          </a:ln>
+        </p:spPr>
+        <p:txBody>
+          <a:bodyPr lIns="0" tIns="0" rIns="0" bIns="0" anchor="ctr">
+            <a:noAutofit/>
+          </a:bodyPr>
+          <a:lstStyle/>
+          <a:p>
+            <a:pPr algn="ctr"/>
+            <a:r>
+              <a:rPr lang="en-US" sz="1100" b="1" dirty="0">
+                <a:solidFill>
+                  <a:srgbClr val="FFFFFF"/>
+                </a:solidFill>
+                <a:latin typeface="Arial"/>
+              </a:rPr>
+              <a:t>4</a:t>
+            </a:r>
+          </a:p>
+        </p:txBody>
+      </p:sp>
+      <p:sp>
+        <p:nvSpPr>
+          <p:cNvPr id="16" name="Text 16"/>
+          <p:cNvSpPr txBox="1"/>
+          <p:nvPr/>
+        </p:nvSpPr>
+        <p:spPr>
+          <a:xfrm>
+            <a:off x="7528560" y="1615440"/>
+            <a:ext cx="3657600" cy="146304"/>
+          </a:xfrm>
+          <a:prstGeom prst="rect">
+            <a:avLst/>
+          </a:prstGeom>
+          <a:noFill/>
+        </p:spPr>
+        <p:txBody>
+          <a:bodyPr wrap="square" lIns="0" tIns="0" rIns="0" bIns="0" anchor="t">
+            <a:noAutofit/>
+          </a:bodyPr>
+          <a:lstStyle/>
+          <a:p>
+            <a:pPr algn="l">
+              <a:spcAft>
+                <a:spcPts val="300"/>
+              </a:spcAft>
+            </a:pPr>
+            <a:r>
+              <a:rPr lang="en-US" sz="1050" b="1" spc="120" dirty="0">
+                <a:solidFill>
+                  <a:srgbClr val="5AB0EE"/>
+                </a:solidFill>
+                <a:latin typeface="Arial"/>
+                <a:cs typeface="Arial"/>
+              </a:rPr>
+              <a:t xml:space="preserve">NY METRO &amp; LONG ISLAND · 11 CLIENTS</a:t>
+            </a:r>
+          </a:p>
+        </p:txBody>
+      </p:sp>
+      <p:sp>
+        <p:nvSpPr>
+          <p:cNvPr id="17" name="Text 17"/>
+          <p:cNvSpPr txBox="1"/>
+          <p:nvPr/>
+        </p:nvSpPr>
+        <p:spPr>
+          <a:xfrm>
+            <a:off x="7528560" y="1840992"/>
+            <a:ext cx="1950720" cy="1402080"/>
+          </a:xfrm>
+          <a:prstGeom prst="rect">
+            <a:avLst/>
+          </a:prstGeom>
+          <a:noFill/>
+        </p:spPr>
+        <p:txBody>
+          <a:bodyPr wrap="square" lIns="0" tIns="0" rIns="0" bIns="0" anchor="t">
+            <a:noAutofit/>
+          </a:bodyPr>
+          <a:lstStyle/>
+          <a:p>
+            <a:pPr algn="l">
+              <a:spcAft>
+                <a:spcPts val="300"/>
+              </a:spcAft>
+            </a:pPr>
+            <a:r>
+              <a:rPr lang="en-US" sz="1100" b="0" spc="0" dirty="0">
+                <a:solidFill>
+                  <a:srgbClr val="C9D2E0"/>
+                </a:solidFill>
+                <a:latin typeface="Arial"/>
+                <a:cs typeface="Arial"/>
+              </a:rPr>
+              <a:t xml:space="preserve">The Smilist</a:t>
+            </a:r>
+          </a:p>
+          <a:p>
+            <a:pPr algn="l">
+              <a:spcAft>
+                <a:spcPts val="300"/>
+              </a:spcAft>
+            </a:pPr>
+            <a:r>
+              <a:rPr lang="en-US" sz="1100" b="0" spc="0" dirty="0">
+                <a:solidFill>
+                  <a:srgbClr val="C9D2E0"/>
+                </a:solidFill>
+                <a:latin typeface="Arial"/>
+                <a:cs typeface="Arial"/>
+              </a:rPr>
+              <a:t xml:space="preserve">Health Plus Management</a:t>
+            </a:r>
+          </a:p>
+          <a:p>
+            <a:pPr algn="l">
+              <a:spcAft>
+                <a:spcPts val="300"/>
+              </a:spcAft>
+            </a:pPr>
+            <a:r>
+              <a:rPr lang="en-US" sz="1100" b="0" spc="0" dirty="0">
+                <a:solidFill>
+                  <a:srgbClr val="C9D2E0"/>
+                </a:solidFill>
+                <a:latin typeface="Arial"/>
+                <a:cs typeface="Arial"/>
+              </a:rPr>
+              <a:t xml:space="preserve">Sanders</a:t>
+            </a:r>
+          </a:p>
+          <a:p>
+            <a:pPr algn="l">
+              <a:spcAft>
+                <a:spcPts val="300"/>
+              </a:spcAft>
+            </a:pPr>
+            <a:r>
+              <a:rPr lang="en-US" sz="1100" b="0" spc="0" dirty="0">
+                <a:solidFill>
+                  <a:srgbClr val="C9D2E0"/>
+                </a:solidFill>
+                <a:latin typeface="Arial"/>
+                <a:cs typeface="Arial"/>
+              </a:rPr>
+              <a:t xml:space="preserve">Bedgear</a:t>
+            </a:r>
+          </a:p>
+          <a:p>
+            <a:pPr algn="l">
+              <a:spcAft>
+                <a:spcPts val="300"/>
+              </a:spcAft>
+            </a:pPr>
+            <a:r>
+              <a:rPr lang="en-US" sz="1100" b="0" spc="0" dirty="0">
+                <a:solidFill>
+                  <a:srgbClr val="C9D2E0"/>
+                </a:solidFill>
+                <a:latin typeface="Arial"/>
+                <a:cs typeface="Arial"/>
+              </a:rPr>
+              <a:t xml:space="preserve">Milberg</a:t>
+            </a:r>
+          </a:p>
+          <a:p>
+            <a:pPr algn="l">
+              <a:spcAft>
+                <a:spcPts val="300"/>
+              </a:spcAft>
+            </a:pPr>
+            <a:r>
+              <a:rPr lang="en-US" sz="1100" b="0" spc="0" dirty="0">
+                <a:solidFill>
+                  <a:srgbClr val="C9D2E0"/>
+                </a:solidFill>
+                <a:latin typeface="Arial"/>
+                <a:cs typeface="Arial"/>
+              </a:rPr>
+              <a:t xml:space="preserve">NY Bariatric Group</a:t>
+            </a:r>
+          </a:p>
+        </p:txBody>
+      </p:sp>
+      <p:sp>
+        <p:nvSpPr>
+          <p:cNvPr id="18" name="Text 18"/>
+          <p:cNvSpPr txBox="1"/>
+          <p:nvPr/>
+        </p:nvSpPr>
+        <p:spPr>
+          <a:xfrm>
+            <a:off x="9540240" y="1840992"/>
+            <a:ext cx="1950720" cy="1402080"/>
+          </a:xfrm>
+          <a:prstGeom prst="rect">
+            <a:avLst/>
+          </a:prstGeom>
+          <a:noFill/>
+        </p:spPr>
+        <p:txBody>
+          <a:bodyPr wrap="square" lIns="0" tIns="0" rIns="0" bIns="0" anchor="t">
+            <a:noAutofit/>
+          </a:bodyPr>
+          <a:lstStyle/>
+          <a:p>
+            <a:pPr algn="l">
+              <a:spcAft>
+                <a:spcPts val="300"/>
+              </a:spcAft>
+            </a:pPr>
+            <a:r>
+              <a:rPr lang="en-US" sz="1100" b="0" spc="0" dirty="0">
+                <a:solidFill>
+                  <a:srgbClr val="C9D2E0"/>
+                </a:solidFill>
+                <a:latin typeface="Arial"/>
+                <a:cs typeface="Arial"/>
+              </a:rPr>
+              <a:t xml:space="preserve">Zicana</a:t>
+            </a:r>
+          </a:p>
+          <a:p>
+            <a:pPr algn="l">
+              <a:spcAft>
+                <a:spcPts val="300"/>
+              </a:spcAft>
+            </a:pPr>
+            <a:r>
+              <a:rPr lang="en-US" sz="1100" b="0" spc="0" dirty="0">
+                <a:solidFill>
+                  <a:srgbClr val="C9D2E0"/>
+                </a:solidFill>
+                <a:latin typeface="Arial"/>
+                <a:cs typeface="Arial"/>
+              </a:rPr>
+              <a:t xml:space="preserve">Cohen Hochman &amp; Allen</a:t>
+            </a:r>
+          </a:p>
+          <a:p>
+            <a:pPr algn="l">
+              <a:spcAft>
+                <a:spcPts val="300"/>
+              </a:spcAft>
+            </a:pPr>
+            <a:r>
+              <a:rPr lang="en-US" sz="1100" b="0" spc="0" dirty="0">
+                <a:solidFill>
+                  <a:srgbClr val="C9D2E0"/>
+                </a:solidFill>
+                <a:latin typeface="Arial"/>
+                <a:cs typeface="Arial"/>
+              </a:rPr>
+              <a:t xml:space="preserve">ProHEALTH Dental (PHD)</a:t>
+            </a:r>
+          </a:p>
+          <a:p>
+            <a:pPr algn="l">
+              <a:spcAft>
+                <a:spcPts val="300"/>
+              </a:spcAft>
+            </a:pPr>
+            <a:r>
+              <a:rPr lang="en-US" sz="1100" b="0" spc="0" dirty="0">
+                <a:solidFill>
+                  <a:srgbClr val="C9D2E0"/>
+                </a:solidFill>
+                <a:latin typeface="Arial"/>
+                <a:cs typeface="Arial"/>
+              </a:rPr>
+              <a:t xml:space="preserve">Stephen K. Seung, Esq.</a:t>
+            </a:r>
+          </a:p>
+          <a:p>
+            <a:pPr algn="l">
+              <a:spcAft>
+                <a:spcPts val="300"/>
+              </a:spcAft>
+            </a:pPr>
+            <a:r>
+              <a:rPr lang="en-US" sz="1100" b="0" spc="0" dirty="0">
+                <a:solidFill>
+                  <a:srgbClr val="C9D2E0"/>
+                </a:solidFill>
+                <a:latin typeface="Arial"/>
+                <a:cs typeface="Arial"/>
+              </a:rPr>
+              <a:t xml:space="preserve">Yankowitz Law Firm</a:t>
+            </a:r>
+          </a:p>
+        </p:txBody>
+      </p:sp>
+      <p:sp>
+        <p:nvSpPr>
+          <p:cNvPr id="19" name="Text 19"/>
+          <p:cNvSpPr txBox="1"/>
+          <p:nvPr/>
+        </p:nvSpPr>
+        <p:spPr>
+          <a:xfrm>
+            <a:off x="7528560" y="3413760"/>
+            <a:ext cx="3657600" cy="146304"/>
+          </a:xfrm>
+          <a:prstGeom prst="rect">
+            <a:avLst/>
+          </a:prstGeom>
+          <a:noFill/>
+        </p:spPr>
+        <p:txBody>
+          <a:bodyPr wrap="square" lIns="0" tIns="0" rIns="0" bIns="0" anchor="t">
+            <a:noAutofit/>
+          </a:bodyPr>
+          <a:lstStyle/>
+          <a:p>
+            <a:pPr algn="l">
+              <a:spcAft>
+                <a:spcPts val="300"/>
+              </a:spcAft>
+            </a:pPr>
+            <a:r>
+              <a:rPr lang="en-US" sz="1050" b="1" spc="120" dirty="0">
+                <a:solidFill>
+                  <a:srgbClr val="5AB0EE"/>
+                </a:solidFill>
+                <a:latin typeface="Arial"/>
+                <a:cs typeface="Arial"/>
+              </a:rPr>
+              <a:t xml:space="preserve">EXPANDING FOOTPRINT</a:t>
+            </a:r>
+          </a:p>
+        </p:txBody>
+      </p:sp>
+      <p:sp>
+        <p:nvSpPr>
+          <p:cNvPr id="20" name="Pin"/>
+          <p:cNvSpPr/>
+          <p:nvPr/>
+        </p:nvSpPr>
+        <p:spPr>
+          <a:xfrm>
+            <a:off x="7528560" y="3651504"/>
+            <a:ext cx="170688" cy="170688"/>
+          </a:xfrm>
+          <a:prstGeom prst="ellipse">
+            <a:avLst/>
+          </a:prstGeom>
+          <a:solidFill>
+            <a:srgbClr val="3B82D6"/>
+          </a:solidFill>
+          <a:ln w="15875">
+            <a:solidFill>
+              <a:srgbClr val="FFFFFF"/>
+            </a:solidFill>
+          </a:ln>
+        </p:spPr>
+        <p:txBody>
+          <a:bodyPr lIns="0" tIns="0" rIns="0" bIns="0" anchor="ctr">
+            <a:noAutofit/>
+          </a:bodyPr>
+          <a:lstStyle/>
+          <a:p>
+            <a:pPr algn="ctr"/>
+            <a:r>
+              <a:rPr lang="en-US" sz="1100" b="1" dirty="0">
+                <a:solidFill>
+                  <a:srgbClr val="FFFFFF"/>
+                </a:solidFill>
+                <a:latin typeface="Arial"/>
+              </a:rPr>
+              <a:t>1</a:t>
+            </a:r>
+          </a:p>
+        </p:txBody>
+      </p:sp>
+      <p:sp>
+        <p:nvSpPr>
+          <p:cNvPr id="21" name="Text 21"/>
+          <p:cNvSpPr txBox="1"/>
+          <p:nvPr/>
+        </p:nvSpPr>
+        <p:spPr>
+          <a:xfrm>
+            <a:off x="7796784" y="3657600"/>
+            <a:ext cx="3718560" cy="329184"/>
+          </a:xfrm>
+          <a:prstGeom prst="rect">
+            <a:avLst/>
+          </a:prstGeom>
+          <a:noFill/>
+        </p:spPr>
+        <p:txBody>
+          <a:bodyPr wrap="square" lIns="0" tIns="0" rIns="0" bIns="0" anchor="t">
+            <a:noAutofit/>
+          </a:bodyPr>
+          <a:lstStyle/>
+          <a:p>
+            <a:pPr algn="l">
+              <a:spcAft>
+                <a:spcPts val="300"/>
+              </a:spcAft>
+            </a:pPr>
+            <a:r>
+              <a:rPr lang="en-US" sz="1200" b="1" spc="0" dirty="0">
+                <a:solidFill>
+                  <a:srgbClr val="FFFFFF"/>
+                </a:solidFill>
+                <a:latin typeface="Arial"/>
+                <a:cs typeface="Arial"/>
+              </a:rPr>
+              <a:t xml:space="preserve">Midwest Eye Consultants / Bridgeview Eye</a:t>
+            </a:r>
+          </a:p>
+          <a:p>
+            <a:pPr algn="l">
+              <a:spcAft>
+                <a:spcPts val="300"/>
+              </a:spcAft>
+            </a:pPr>
+            <a:r>
+              <a:rPr lang="en-US" sz="1000" b="0" spc="0" dirty="0">
+                <a:solidFill>
+                  <a:srgbClr val="8B97AB"/>
+                </a:solidFill>
+                <a:latin typeface="Arial"/>
+                <a:cs typeface="Arial"/>
+              </a:rPr>
+              <a:t xml:space="preserve">Wabash, IN</a:t>
+            </a:r>
+          </a:p>
+        </p:txBody>
+      </p:sp>
+      <p:sp>
+        <p:nvSpPr>
+          <p:cNvPr id="22" name="Pin"/>
+          <p:cNvSpPr/>
+          <p:nvPr/>
+        </p:nvSpPr>
+        <p:spPr>
+          <a:xfrm>
+            <a:off x="7528560" y="4053840"/>
+            <a:ext cx="170688" cy="170688"/>
+          </a:xfrm>
+          <a:prstGeom prst="ellipse">
+            <a:avLst/>
+          </a:prstGeom>
+          <a:solidFill>
+            <a:srgbClr val="3B82D6"/>
+          </a:solidFill>
+          <a:ln w="15875">
+            <a:solidFill>
+              <a:srgbClr val="FFFFFF"/>
+            </a:solidFill>
+          </a:ln>
+        </p:spPr>
+        <p:txBody>
+          <a:bodyPr lIns="0" tIns="0" rIns="0" bIns="0" anchor="ctr">
+            <a:noAutofit/>
+          </a:bodyPr>
+          <a:lstStyle/>
+          <a:p>
+            <a:pPr algn="ctr"/>
+            <a:r>
+              <a:rPr lang="en-US" sz="1100" b="1" dirty="0">
+                <a:solidFill>
+                  <a:srgbClr val="FFFFFF"/>
+                </a:solidFill>
+                <a:latin typeface="Arial"/>
+              </a:rPr>
+              <a:t>2</a:t>
+            </a:r>
+          </a:p>
+        </p:txBody>
+      </p:sp>
+      <p:sp>
+        <p:nvSpPr>
+          <p:cNvPr id="23" name="Text 23"/>
+          <p:cNvSpPr txBox="1"/>
+          <p:nvPr/>
+        </p:nvSpPr>
+        <p:spPr>
+          <a:xfrm>
+            <a:off x="7796784" y="4059936"/>
+            <a:ext cx="3718560" cy="329184"/>
+          </a:xfrm>
+          <a:prstGeom prst="rect">
+            <a:avLst/>
+          </a:prstGeom>
+          <a:noFill/>
+        </p:spPr>
+        <p:txBody>
+          <a:bodyPr wrap="square" lIns="0" tIns="0" rIns="0" bIns="0" anchor="t">
+            <a:noAutofit/>
+          </a:bodyPr>
+          <a:lstStyle/>
+          <a:p>
+            <a:pPr algn="l">
+              <a:spcAft>
+                <a:spcPts val="300"/>
+              </a:spcAft>
+            </a:pPr>
+            <a:r>
+              <a:rPr lang="en-US" sz="1200" b="1" spc="0" dirty="0">
+                <a:solidFill>
+                  <a:srgbClr val="FFFFFF"/>
+                </a:solidFill>
+                <a:latin typeface="Arial"/>
+                <a:cs typeface="Arial"/>
+              </a:rPr>
+              <a:t xml:space="preserve">MMSIC</a:t>
+            </a:r>
+          </a:p>
+          <a:p>
+            <a:pPr algn="l">
+              <a:spcAft>
+                <a:spcPts val="300"/>
+              </a:spcAft>
+            </a:pPr>
+            <a:r>
+              <a:rPr lang="en-US" sz="1000" b="0" spc="0" dirty="0">
+                <a:solidFill>
+                  <a:srgbClr val="8B97AB"/>
+                </a:solidFill>
+                <a:latin typeface="Arial"/>
+                <a:cs typeface="Arial"/>
+              </a:rPr>
+              <a:t xml:space="preserve">Lansing, MI</a:t>
+            </a:r>
+          </a:p>
+        </p:txBody>
+      </p:sp>
+      <p:sp>
+        <p:nvSpPr>
+          <p:cNvPr id="24" name="Pin"/>
+          <p:cNvSpPr/>
+          <p:nvPr/>
+        </p:nvSpPr>
+        <p:spPr>
+          <a:xfrm>
+            <a:off x="7528560" y="4456176"/>
+            <a:ext cx="170688" cy="170688"/>
+          </a:xfrm>
+          <a:prstGeom prst="ellipse">
+            <a:avLst/>
+          </a:prstGeom>
+          <a:solidFill>
+            <a:srgbClr val="3B82D6"/>
+          </a:solidFill>
+          <a:ln w="15875">
+            <a:solidFill>
+              <a:srgbClr val="FFFFFF"/>
+            </a:solidFill>
+          </a:ln>
+        </p:spPr>
+        <p:txBody>
+          <a:bodyPr lIns="0" tIns="0" rIns="0" bIns="0" anchor="ctr">
+            <a:noAutofit/>
+          </a:bodyPr>
+          <a:lstStyle/>
+          <a:p>
+            <a:pPr algn="ctr"/>
+            <a:r>
+              <a:rPr lang="en-US" sz="1100" b="1" dirty="0">
+                <a:solidFill>
+                  <a:srgbClr val="FFFFFF"/>
+                </a:solidFill>
+                <a:latin typeface="Arial"/>
+              </a:rPr>
+              <a:t>3</a:t>
+            </a:r>
+          </a:p>
+        </p:txBody>
+      </p:sp>
+      <p:sp>
+        <p:nvSpPr>
+          <p:cNvPr id="25" name="Text 25"/>
+          <p:cNvSpPr txBox="1"/>
+          <p:nvPr/>
+        </p:nvSpPr>
+        <p:spPr>
+          <a:xfrm>
+            <a:off x="7796784" y="4462272"/>
+            <a:ext cx="3718560" cy="329184"/>
+          </a:xfrm>
+          <a:prstGeom prst="rect">
+            <a:avLst/>
+          </a:prstGeom>
+          <a:noFill/>
+        </p:spPr>
+        <p:txBody>
+          <a:bodyPr wrap="square" lIns="0" tIns="0" rIns="0" bIns="0" anchor="t">
+            <a:noAutofit/>
+          </a:bodyPr>
+          <a:lstStyle/>
+          <a:p>
+            <a:pPr algn="l">
+              <a:spcAft>
+                <a:spcPts val="300"/>
+              </a:spcAft>
+            </a:pPr>
+            <a:r>
+              <a:rPr lang="en-US" sz="1200" b="1" spc="0" dirty="0">
+                <a:solidFill>
+                  <a:srgbClr val="FFFFFF"/>
+                </a:solidFill>
+                <a:latin typeface="Arial"/>
+                <a:cs typeface="Arial"/>
+              </a:rPr>
+              <a:t xml:space="preserve">MyServiceReady</a:t>
+            </a:r>
+          </a:p>
+          <a:p>
+            <a:pPr algn="l">
+              <a:spcAft>
+                <a:spcPts val="300"/>
+              </a:spcAft>
+            </a:pPr>
+            <a:r>
+              <a:rPr lang="en-US" sz="1000" b="0" spc="0" dirty="0">
+                <a:solidFill>
+                  <a:srgbClr val="8B97AB"/>
+                </a:solidFill>
+                <a:latin typeface="Arial"/>
+                <a:cs typeface="Arial"/>
+              </a:rPr>
+              <a:t xml:space="preserve">West Palm Beach, FL</a:t>
+            </a:r>
+          </a:p>
+        </p:txBody>
+      </p:sp>
+      <p:sp>
+        <p:nvSpPr>
+          <p:cNvPr id="26" name="Pin"/>
+          <p:cNvSpPr/>
+          <p:nvPr/>
+        </p:nvSpPr>
+        <p:spPr>
+          <a:xfrm>
+            <a:off x="7528560" y="4858512"/>
+            <a:ext cx="170688" cy="170688"/>
+          </a:xfrm>
+          <a:prstGeom prst="ellipse">
+            <a:avLst/>
+          </a:prstGeom>
+          <a:solidFill>
+            <a:srgbClr val="3B82D6"/>
+          </a:solidFill>
+          <a:ln w="15875">
+            <a:solidFill>
+              <a:srgbClr val="FFFFFF"/>
+            </a:solidFill>
+          </a:ln>
+        </p:spPr>
+        <p:txBody>
+          <a:bodyPr lIns="0" tIns="0" rIns="0" bIns="0" anchor="ctr">
+            <a:noAutofit/>
+          </a:bodyPr>
+          <a:lstStyle/>
+          <a:p>
+            <a:pPr algn="ctr"/>
+            <a:r>
+              <a:rPr lang="en-US" sz="1100" b="1" dirty="0">
+                <a:solidFill>
+                  <a:srgbClr val="FFFFFF"/>
+                </a:solidFill>
+                <a:latin typeface="Arial"/>
+              </a:rPr>
+              <a:t>4</a:t>
+            </a:r>
+          </a:p>
+        </p:txBody>
+      </p:sp>
+      <p:sp>
+        <p:nvSpPr>
+          <p:cNvPr id="27" name="Text 27"/>
+          <p:cNvSpPr txBox="1"/>
+          <p:nvPr/>
+        </p:nvSpPr>
+        <p:spPr>
+          <a:xfrm>
+            <a:off x="7796784" y="4864608"/>
+            <a:ext cx="3718560" cy="329184"/>
+          </a:xfrm>
+          <a:prstGeom prst="rect">
+            <a:avLst/>
+          </a:prstGeom>
+          <a:noFill/>
+        </p:spPr>
+        <p:txBody>
+          <a:bodyPr wrap="square" lIns="0" tIns="0" rIns="0" bIns="0" anchor="t">
+            <a:noAutofit/>
+          </a:bodyPr>
+          <a:lstStyle/>
+          <a:p>
+            <a:pPr algn="l">
+              <a:spcAft>
+                <a:spcPts val="300"/>
+              </a:spcAft>
+            </a:pPr>
+            <a:r>
+              <a:rPr lang="en-US" sz="1200" b="1" spc="0" dirty="0">
+                <a:solidFill>
+                  <a:srgbClr val="FFFFFF"/>
+                </a:solidFill>
+                <a:latin typeface="Arial"/>
+                <a:cs typeface="Arial"/>
+              </a:rPr>
+              <a:t xml:space="preserve">Roller Weight Loss</a:t>
+            </a:r>
+          </a:p>
+          <a:p>
+            <a:pPr algn="l">
+              <a:spcAft>
+                <a:spcPts val="300"/>
+              </a:spcAft>
+            </a:pPr>
+            <a:r>
+              <a:rPr lang="en-US" sz="1000" b="0" spc="0" dirty="0">
+                <a:solidFill>
+                  <a:srgbClr val="8B97AB"/>
+                </a:solidFill>
+                <a:latin typeface="Arial"/>
+                <a:cs typeface="Arial"/>
+              </a:rPr>
+              <a:t xml:space="preserve">Fort Smith, AR</a:t>
+            </a:r>
+          </a:p>
+        </p:txBody>
+      </p:sp>
+      <p:sp>
+        <p:nvSpPr>
+          <p:cNvPr id="28" name="Text 28"/>
+          <p:cNvSpPr txBox="1"/>
+          <p:nvPr/>
+        </p:nvSpPr>
+        <p:spPr>
+          <a:xfrm>
+            <a:off x="762000" y="5852160"/>
+            <a:ext cx="10668000" cy="121920"/>
+          </a:xfrm>
+          <a:prstGeom prst="rect">
+            <a:avLst/>
+          </a:prstGeom>
+          <a:noFill/>
+        </p:spPr>
+        <p:txBody>
+          <a:bodyPr wrap="square" lIns="0" tIns="0" rIns="0" bIns="0" anchor="t">
+            <a:noAutofit/>
+          </a:bodyPr>
+          <a:lstStyle/>
+          <a:p>
+            <a:pPr algn="l">
+              <a:spcAft>
+                <a:spcPts val="300"/>
+              </a:spcAft>
+            </a:pPr>
+            <a:r>
+              <a:rPr lang="en-US" sz="1000" b="0" spc="0" dirty="0">
+                <a:solidFill>
+                  <a:srgbClr val="8B97AB"/>
+                </a:solidFill>
+                <a:latin typeface="Arial"/>
+                <a:cs typeface="Arial"/>
+              </a:rPr>
+              <a:t xml:space="preserve">Offices: Westbury NY · Roslyn Heights NY · Fort Lauderdale FL. Plus Link &amp; Associates (location pending confirmation). Client roster and locations as of September 2026.</a:t>
+            </a:r>
+          </a:p>
+        </p:txBody>
+      </p:sp>
+      <p:cxnSp>
+        <p:nvCxnSpPr>
+          <p:cNvPr id="29" name="Rule"/>
+          <p:cNvCxnSpPr/>
+          <p:nvPr/>
+        </p:nvCxnSpPr>
+        <p:spPr>
+          <a:xfrm>
+            <a:off x="762000" y="6333744"/>
+            <a:ext cx="10668000" cy="0"/>
+          </a:xfrm>
+          <a:prstGeom prst="line">
+            <a:avLst/>
+          </a:prstGeom>
+          <a:ln w="9525">
+            <a:solidFill>
+              <a:srgbClr val="2E3A4D"/>
+            </a:solidFill>
+          </a:ln>
+        </p:spPr>
+      </p:cxnSp>
+      <p:sp>
+        <p:nvSpPr>
+          <p:cNvPr id="30" name="Text 30"/>
+          <p:cNvSpPr txBox="1"/>
+          <p:nvPr/>
+        </p:nvSpPr>
+        <p:spPr>
+          <a:xfrm>
+            <a:off x="762000" y="6473952"/>
+            <a:ext cx="3657600" cy="134112"/>
+          </a:xfrm>
+          <a:prstGeom prst="rect">
+            <a:avLst/>
+          </a:prstGeom>
+          <a:noFill/>
+        </p:spPr>
+        <p:txBody>
+          <a:bodyPr wrap="square" lIns="0" tIns="0" rIns="0" bIns="0" anchor="t">
+            <a:noAutofit/>
+          </a:bodyPr>
+          <a:lstStyle/>
+          <a:p>
+            <a:pPr algn="l">
+              <a:spcAft>
+                <a:spcPts val="300"/>
+              </a:spcAft>
+            </a:pPr>
+            <a:r>
+              <a:rPr lang="en-US" sz="1100" b="0" spc="0" dirty="0">
+                <a:solidFill>
+                  <a:srgbClr val="6B778C"/>
+                </a:solidFill>
+                <a:latin typeface="Arial"/>
+                <a:cs typeface="Arial"/>
+              </a:rPr>
+              <a:t xml:space="preserve">DSS · Confidential</a:t>
+            </a:r>
+          </a:p>
+        </p:txBody>
+      </p:sp>
+      <p:sp>
+        <p:nvSpPr>
+          <p:cNvPr id="31" name="Text 31"/>
+          <p:cNvSpPr txBox="1"/>
+          <p:nvPr/>
+        </p:nvSpPr>
+        <p:spPr>
+          <a:xfrm>
+            <a:off x="9601200" y="6473952"/>
+            <a:ext cx="1828800" cy="134112"/>
+          </a:xfrm>
+          <a:prstGeom prst="rect">
+            <a:avLst/>
+          </a:prstGeom>
+          <a:noFill/>
+        </p:spPr>
+        <p:txBody>
+          <a:bodyPr wrap="square" lIns="0" tIns="0" rIns="0" bIns="0" anchor="t">
+            <a:noAutofit/>
+          </a:bodyPr>
+          <a:lstStyle/>
+          <a:p>
+            <a:pPr algn="r">
+              <a:spcAft>
+                <a:spcPts val="300"/>
+              </a:spcAft>
+            </a:pPr>
+            <a:r>
+              <a:rPr lang="en-US" sz="1100" b="0" spc="0" dirty="0">
+                <a:solidFill>
+                  <a:srgbClr val="6B778C"/>
+                </a:solidFill>
+                <a:latin typeface="Arial"/>
+                <a:cs typeface="Arial"/>
+              </a:rPr>
+              <a:t xml:space="preserve">06</a:t>
+            </a:r>
+          </a:p>
+        </p:txBody>
+      </p:sp>
     </p:spTree>
   </p:cSld>
   <p:clrMapOvr>

</xml_diff>